<commit_message>
Update TechNet deck with project questionnaire and team
Co-authored-by: arena-agent <297053741+arena-agent@users.noreply.github.com>
</commit_message>
<xml_diff>
--- a/presentations/СинтексПруф_TechNet_ДГУ_2026.pptx
+++ b/presentations/СинтексПруф_TechNet_ДГУ_2026.pptx
@@ -3222,39 +3222,39 @@
         </p:nvSpPr>
         <p:spPr>
           <a:xfrm>
-            <a:off x="635000" y="3771900"/>
-            <a:ext cx="8445500" cy="718820"/>
-          </a:xfrm>
-          <a:prstGeom prst="rect">
-            <a:avLst/>
-          </a:prstGeom>
-          <a:noFill/>
-        </p:spPr>
-        <p:txBody>
-          <a:bodyPr wrap="none" tIns="0" bIns="0" lIns="0" rIns="0" anchor="t">
-            <a:noAutofit/>
-          </a:bodyPr>
-          <a:lstStyle/>
-          <a:p>
-            <a:pPr algn="l">
-              <a:lnSpc>
-                <a:spcPts val="2680"/>
-              </a:lnSpc>
-              <a:spcBef>
-                <a:spcPts val="0"/>
-              </a:spcBef>
-              <a:spcAft>
-                <a:spcPts val="0"/>
-              </a:spcAft>
-            </a:pPr>
-            <a:r>
-              <a:rPr sz="2000" b="0">
+            <a:off x="635000" y="3733800"/>
+            <a:ext cx="8521700" cy="912114"/>
+          </a:xfrm>
+          <a:prstGeom prst="rect">
+            <a:avLst/>
+          </a:prstGeom>
+          <a:noFill/>
+        </p:spPr>
+        <p:txBody>
+          <a:bodyPr wrap="none" tIns="0" bIns="0" lIns="0" rIns="0" anchor="t">
+            <a:noAutofit/>
+          </a:bodyPr>
+          <a:lstStyle/>
+          <a:p>
+            <a:pPr algn="l">
+              <a:lnSpc>
+                <a:spcPts val="2294"/>
+              </a:lnSpc>
+              <a:spcBef>
+                <a:spcPts val="0"/>
+              </a:spcBef>
+              <a:spcAft>
+                <a:spcPts val="0"/>
+              </a:spcAft>
+            </a:pPr>
+            <a:r>
+              <a:rPr sz="1850" b="0">
                 <a:solidFill>
                   <a:srgbClr val="FFFFFF"/>
                 </a:solidFill>
                 <a:latin typeface="Arial"/>
               </a:rPr>
-              <a:t>Платформа статического анализа_x000B_и ИИ-ревью программного кода</a:t>
+              <a:t>Облачная система семантического анализа_x000B_и ИИ-ревью исходного кода_x000B_для образовательных учреждений</a:t>
             </a:r>
           </a:p>
         </p:txBody>
@@ -3344,7 +3344,7 @@
                 </a:solidFill>
                 <a:latin typeface="Arial"/>
               </a:rPr>
-              <a:t>StevenScreamches@ya.ru • +7 (928) 218-30-30</a:t>
+              <a:t>aldarfgfg@gmail.com • +7 (928) 218-30-30</a:t>
             </a:r>
           </a:p>
         </p:txBody>
@@ -3389,7 +3389,7 @@
                 </a:solidFill>
                 <a:latin typeface="Arial"/>
               </a:rPr>
-              <a:t>Источник: «Акселератор.pdf», с. 1, 6 • Программа ДГУ TechNet</a:t>
+              <a:t>Источники: анкета проекта (приложенное изображение); «Акселератор.pdf», с. 1, 6.</a:t>
             </a:r>
           </a:p>
         </p:txBody>
@@ -6452,7 +6452,7 @@
                 </a:solidFill>
                 <a:latin typeface="Arial"/>
               </a:rPr>
-              <a:t>StevenScreamches@ya.ru • +7 (928) 218-30-30</a:t>
+              <a:t>aldarfgfg@gmail.com • +7 (928) 218-30-30</a:t>
             </a:r>
           </a:p>
         </p:txBody>
@@ -8634,39 +8634,39 @@
         </p:nvSpPr>
         <p:spPr>
           <a:xfrm>
-            <a:off x="635000" y="5842000"/>
-            <a:ext cx="6375400" cy="221792"/>
-          </a:xfrm>
-          <a:prstGeom prst="rect">
-            <a:avLst/>
-          </a:prstGeom>
-          <a:noFill/>
-        </p:spPr>
-        <p:txBody>
-          <a:bodyPr wrap="none" tIns="0" bIns="0" lIns="0" rIns="0" anchor="t">
-            <a:noAutofit/>
-          </a:bodyPr>
-          <a:lstStyle/>
-          <a:p>
-            <a:pPr algn="l">
-              <a:lnSpc>
-                <a:spcPts val="1446"/>
-              </a:lnSpc>
-              <a:spcBef>
-                <a:spcPts val="0"/>
-              </a:spcBef>
-              <a:spcAft>
-                <a:spcPts val="0"/>
-              </a:spcAft>
-            </a:pPr>
-            <a:r>
-              <a:rPr sz="1130" b="0">
+            <a:off x="635000" y="5816600"/>
+            <a:ext cx="6553200" cy="218541"/>
+          </a:xfrm>
+          <a:prstGeom prst="rect">
+            <a:avLst/>
+          </a:prstGeom>
+          <a:noFill/>
+        </p:spPr>
+        <p:txBody>
+          <a:bodyPr wrap="none" tIns="0" bIns="0" lIns="0" rIns="0" anchor="t">
+            <a:noAutofit/>
+          </a:bodyPr>
+          <a:lstStyle/>
+          <a:p>
+            <a:pPr algn="l">
+              <a:lnSpc>
+                <a:spcPts val="1420"/>
+              </a:lnSpc>
+              <a:spcBef>
+                <a:spcPts val="0"/>
+              </a:spcBef>
+              <a:spcAft>
+                <a:spcPts val="0"/>
+              </a:spcAft>
+            </a:pPr>
+            <a:r>
+              <a:rPr sz="1110" b="0">
                 <a:solidFill>
                   <a:srgbClr val="57228A"/>
                 </a:solidFill>
                 <a:latin typeface="Arial"/>
               </a:rPr>
-              <a:t>Стек из питча: React / Next.js • Python / FastAPI • Docker</a:t>
+              <a:t>Стек: React / Next.js • Python / FastAPI • Docker</a:t>
             </a:r>
           </a:p>
         </p:txBody>
@@ -8679,39 +8679,84 @@
         </p:nvSpPr>
         <p:spPr>
           <a:xfrm>
+            <a:off x="635000" y="6057900"/>
+            <a:ext cx="6565900" cy="341223"/>
+          </a:xfrm>
+          <a:prstGeom prst="rect">
+            <a:avLst/>
+          </a:prstGeom>
+          <a:noFill/>
+        </p:spPr>
+        <p:txBody>
+          <a:bodyPr wrap="none" tIns="0" bIns="0" lIns="0" rIns="0" anchor="t">
+            <a:noAutofit/>
+          </a:bodyPr>
+          <a:lstStyle/>
+          <a:p>
+            <a:pPr algn="l">
+              <a:lnSpc>
+                <a:spcPts val="1193"/>
+              </a:lnSpc>
+              <a:spcBef>
+                <a:spcPts val="0"/>
+              </a:spcBef>
+              <a:spcAft>
+                <a:spcPts val="0"/>
+              </a:spcAft>
+            </a:pPr>
+            <a:r>
+              <a:rPr sz="1019" b="0">
+                <a:solidFill>
+                  <a:srgbClr val="57228A"/>
+                </a:solidFill>
+                <a:latin typeface="Arial"/>
+              </a:rPr>
+              <a:t>По анкете: системы обработки больших данных, ML и ИИ._x000B_Сквозная технология — технологии искусственного интеллекта.</a:t>
+            </a:r>
+          </a:p>
+        </p:txBody>
+      </p:sp>
+      <p:sp>
+        <p:nvSpPr>
+          <p:cNvPr id="26" name="TextBox 25"/>
+          <p:cNvSpPr txBox="1"/>
+          <p:nvPr/>
+        </p:nvSpPr>
+        <p:spPr>
+          <a:xfrm>
             <a:off x="609600" y="6502400"/>
-            <a:ext cx="10756900" cy="142240"/>
-          </a:xfrm>
-          <a:prstGeom prst="rect">
-            <a:avLst/>
-          </a:prstGeom>
-          <a:noFill/>
-        </p:spPr>
-        <p:txBody>
-          <a:bodyPr wrap="none" tIns="0" bIns="0" lIns="0" rIns="0" anchor="t">
-            <a:noAutofit/>
-          </a:bodyPr>
-          <a:lstStyle/>
-          <a:p>
-            <a:pPr algn="l">
-              <a:lnSpc>
-                <a:spcPts val="819"/>
-              </a:lnSpc>
-              <a:spcBef>
-                <a:spcPts val="0"/>
-              </a:spcBef>
-              <a:spcAft>
-                <a:spcPts val="0"/>
-              </a:spcAft>
-            </a:pPr>
-            <a:r>
-              <a:rPr sz="819" b="0">
+            <a:ext cx="10756900" cy="139700"/>
+          </a:xfrm>
+          <a:prstGeom prst="rect">
+            <a:avLst/>
+          </a:prstGeom>
+          <a:noFill/>
+        </p:spPr>
+        <p:txBody>
+          <a:bodyPr wrap="none" tIns="0" bIns="0" lIns="0" rIns="0" anchor="t">
+            <a:noAutofit/>
+          </a:bodyPr>
+          <a:lstStyle/>
+          <a:p>
+            <a:pPr algn="l">
+              <a:lnSpc>
+                <a:spcPts val="800"/>
+              </a:lnSpc>
+              <a:spcBef>
+                <a:spcPts val="0"/>
+              </a:spcBef>
+              <a:spcAft>
+                <a:spcPts val="0"/>
+              </a:spcAft>
+            </a:pPr>
+            <a:r>
+              <a:rPr sz="800" b="0">
                 <a:solidFill>
                   <a:srgbClr val="5A526C"/>
                 </a:solidFill>
                 <a:latin typeface="Arial"/>
               </a:rPr>
-              <a:t>Источник стека: «Акселератор.pdf», с. 5; схема — представление продукта из питча.</a:t>
+              <a:t>Стек: «Акселератор.pdf», с. 5; классификация технологий — анкета проекта.</a:t>
             </a:r>
           </a:p>
         </p:txBody>
@@ -11197,38 +11242,38 @@
         <p:spPr>
           <a:xfrm>
             <a:off x="952500" y="2374900"/>
-            <a:ext cx="6629400" cy="301447"/>
-          </a:xfrm>
-          <a:prstGeom prst="rect">
-            <a:avLst/>
-          </a:prstGeom>
-          <a:noFill/>
-        </p:spPr>
-        <p:txBody>
-          <a:bodyPr wrap="none" tIns="0" bIns="0" lIns="0" rIns="0" anchor="t">
-            <a:noAutofit/>
-          </a:bodyPr>
-          <a:lstStyle/>
-          <a:p>
-            <a:pPr algn="l">
-              <a:lnSpc>
-                <a:spcPts val="2073"/>
-              </a:lnSpc>
-              <a:spcBef>
-                <a:spcPts val="0"/>
-              </a:spcBef>
-              <a:spcAft>
-                <a:spcPts val="0"/>
-              </a:spcAft>
-            </a:pPr>
-            <a:r>
-              <a:rPr sz="1620" b="1">
+            <a:ext cx="6629400" cy="288442"/>
+          </a:xfrm>
+          <a:prstGeom prst="rect">
+            <a:avLst/>
+          </a:prstGeom>
+          <a:noFill/>
+        </p:spPr>
+        <p:txBody>
+          <a:bodyPr wrap="none" tIns="0" bIns="0" lIns="0" rIns="0" anchor="t">
+            <a:noAutofit/>
+          </a:bodyPr>
+          <a:lstStyle/>
+          <a:p>
+            <a:pPr algn="l">
+              <a:lnSpc>
+                <a:spcPts val="1971"/>
+              </a:lnSpc>
+              <a:spcBef>
+                <a:spcPts val="0"/>
+              </a:spcBef>
+              <a:spcAft>
+                <a:spcPts val="0"/>
+              </a:spcAft>
+            </a:pPr>
+            <a:r>
+              <a:rPr sz="1540" b="1">
                 <a:solidFill>
                   <a:srgbClr val="1F1931"/>
                 </a:solidFill>
                 <a:latin typeface="Arial"/>
               </a:rPr>
-              <a:t>TechNet / ИТ-команды</a:t>
+              <a:t>Образовательные учреждения / EduNet</a:t>
             </a:r>
           </a:p>
         </p:txBody>
@@ -11242,7 +11287,7 @@
         <p:spPr>
           <a:xfrm>
             <a:off x="952500" y="2730500"/>
-            <a:ext cx="6604000" cy="454253"/>
+            <a:ext cx="6604000" cy="246176"/>
           </a:xfrm>
           <a:prstGeom prst="rect">
             <a:avLst/>
@@ -11273,7 +11318,7 @@
                 </a:solidFill>
                 <a:latin typeface="Arial"/>
               </a:rPr>
-              <a:t>Первичный фильтр перед ручным ревью; покупатель — руководитель_x000B_разработки.</a:t>
+              <a:t>Проверка кода студентов и понятная обратная связь преподавателю.</a:t>
             </a:r>
           </a:p>
         </p:txBody>
@@ -11408,7 +11453,7 @@
                 </a:solidFill>
                 <a:latin typeface="Arial"/>
               </a:rPr>
-              <a:t>EduNet / преподаватели</a:t>
+              <a:t>ИТ-команды / рынок TechNet</a:t>
             </a:r>
           </a:p>
         </p:txBody>
@@ -11453,7 +11498,7 @@
                 </a:solidFill>
                 <a:latin typeface="Arial"/>
               </a:rPr>
-              <a:t>Потоковая проверка работ и понятная обратная связь обучающимся.</a:t>
+              <a:t>Первичный фильтр до ручного Code Review для руководителя разработки.</a:t>
             </a:r>
           </a:p>
         </p:txBody>
@@ -11647,7 +11692,7 @@
         <p:spPr>
           <a:xfrm>
             <a:off x="609600" y="5829300"/>
-            <a:ext cx="7505700" cy="533400"/>
+            <a:ext cx="7162800" cy="533400"/>
           </a:xfrm>
           <a:prstGeom prst="roundRect">
             <a:avLst>
@@ -11694,7 +11739,7 @@
         <p:spPr>
           <a:xfrm>
             <a:off x="774700" y="5956300"/>
-            <a:ext cx="7251700" cy="234797"/>
+            <a:ext cx="6858000" cy="234797"/>
           </a:xfrm>
           <a:prstGeom prst="rect">
             <a:avLst/>
@@ -11770,7 +11815,7 @@
                 </a:solidFill>
                 <a:latin typeface="Arial"/>
               </a:rPr>
-              <a:t>Сегменты из «Акселератор.pdf», с. 4; модель оплаты — гипотеза, не факт продаж.</a:t>
+              <a:t>Фокус на образовании и рынок TechNet — анкета проекта; модель оплаты — гипотеза.</a:t>
             </a:r>
           </a:p>
         </p:txBody>
@@ -11825,53 +11870,143 @@
         </p:nvSpPr>
         <p:spPr>
           <a:xfrm>
-            <a:off x="622300" y="1714500"/>
-            <a:ext cx="7785100" cy="317703"/>
-          </a:xfrm>
-          <a:prstGeom prst="rect">
-            <a:avLst/>
-          </a:prstGeom>
-          <a:noFill/>
-        </p:spPr>
-        <p:txBody>
-          <a:bodyPr wrap="none" tIns="0" bIns="0" lIns="0" rIns="0" anchor="t">
-            <a:noAutofit/>
-          </a:bodyPr>
-          <a:lstStyle/>
-          <a:p>
-            <a:pPr algn="l">
-              <a:lnSpc>
-                <a:spcPts val="2201"/>
-              </a:lnSpc>
-              <a:spcBef>
-                <a:spcPts val="0"/>
-              </a:spcBef>
-              <a:spcAft>
-                <a:spcPts val="0"/>
-              </a:spcAft>
-            </a:pPr>
-            <a:r>
-              <a:rPr sz="1720" b="1">
+            <a:off x="622300" y="1689100"/>
+            <a:ext cx="7581900" cy="333959"/>
+          </a:xfrm>
+          <a:prstGeom prst="rect">
+            <a:avLst/>
+          </a:prstGeom>
+          <a:noFill/>
+        </p:spPr>
+        <p:txBody>
+          <a:bodyPr wrap="none" tIns="0" bIns="0" lIns="0" rIns="0" anchor="t">
+            <a:noAutofit/>
+          </a:bodyPr>
+          <a:lstStyle/>
+          <a:p>
+            <a:pPr algn="l">
+              <a:lnSpc>
+                <a:spcPts val="2329"/>
+              </a:lnSpc>
+              <a:spcBef>
+                <a:spcPts val="0"/>
+              </a:spcBef>
+              <a:spcAft>
+                <a:spcPts val="0"/>
+              </a:spcAft>
+            </a:pPr>
+            <a:r>
+              <a:rPr sz="1820" b="1">
                 <a:solidFill>
                   <a:srgbClr val="1F1931"/>
                 </a:solidFill>
                 <a:latin typeface="Arial"/>
               </a:rPr>
-              <a:t>В исходных материалах указан один контакт проекта</a:t>
-            </a:r>
-          </a:p>
-        </p:txBody>
-      </p:sp>
-      <p:sp>
-        <p:nvSpPr>
-          <p:cNvPr id="4" name="Rounded Rectangle 3"/>
+              <a:t>Команда проекта: 5 участников</a:t>
+            </a:r>
+          </a:p>
+        </p:txBody>
+      </p:sp>
+      <p:sp>
+        <p:nvSpPr>
+          <p:cNvPr id="4" name="TextBox 3"/>
+          <p:cNvSpPr txBox="1"/>
+          <p:nvPr/>
+        </p:nvSpPr>
+        <p:spPr>
+          <a:xfrm>
+            <a:off x="622300" y="2082800"/>
+            <a:ext cx="4991100" cy="220167"/>
+          </a:xfrm>
+          <a:prstGeom prst="rect">
+            <a:avLst/>
+          </a:prstGeom>
+          <a:noFill/>
+        </p:spPr>
+        <p:txBody>
+          <a:bodyPr wrap="none" tIns="0" bIns="0" lIns="0" rIns="0" anchor="t">
+            <a:noAutofit/>
+          </a:bodyPr>
+          <a:lstStyle/>
+          <a:p>
+            <a:pPr algn="l">
+              <a:lnSpc>
+                <a:spcPts val="1433"/>
+              </a:lnSpc>
+              <a:spcBef>
+                <a:spcPts val="0"/>
+              </a:spcBef>
+              <a:spcAft>
+                <a:spcPts val="0"/>
+              </a:spcAft>
+            </a:pPr>
+            <a:r>
+              <a:rPr sz="1120" b="0">
+                <a:solidFill>
+                  <a:srgbClr val="57228A"/>
+                </a:solidFill>
+                <a:latin typeface="Arial"/>
+              </a:rPr>
+              <a:t>Лидер: aldarfgfg@gmail.com • +7 (928) 218-30-30</a:t>
+            </a:r>
+          </a:p>
+        </p:txBody>
+      </p:sp>
+      <p:sp>
+        <p:nvSpPr>
+          <p:cNvPr id="5" name="TextBox 4"/>
+          <p:cNvSpPr txBox="1"/>
+          <p:nvPr/>
+        </p:nvSpPr>
+        <p:spPr>
+          <a:xfrm>
+            <a:off x="5511800" y="2247900"/>
+            <a:ext cx="2159000" cy="181152"/>
+          </a:xfrm>
+          <a:prstGeom prst="rect">
+            <a:avLst/>
+          </a:prstGeom>
+          <a:noFill/>
+        </p:spPr>
+        <p:txBody>
+          <a:bodyPr wrap="none" tIns="0" bIns="0" lIns="0" rIns="0" anchor="t">
+            <a:noAutofit/>
+          </a:bodyPr>
+          <a:lstStyle/>
+          <a:p>
+            <a:pPr algn="r">
+              <a:lnSpc>
+                <a:spcPts val="1126"/>
+              </a:lnSpc>
+              <a:spcBef>
+                <a:spcPts val="0"/>
+              </a:spcBef>
+              <a:spcAft>
+                <a:spcPts val="0"/>
+              </a:spcAft>
+            </a:pPr>
+            <a:r>
+              <a:rPr sz="880" b="0">
+                <a:solidFill>
+                  <a:srgbClr val="5A526C"/>
+                </a:solidFill>
+                <a:latin typeface="Arial"/>
+              </a:rPr>
+              <a:t>UnTI ID / Leader ID</a:t>
+            </a:r>
+          </a:p>
+        </p:txBody>
+      </p:sp>
+      <p:sp>
+        <p:nvSpPr>
+          <p:cNvPr id="6" name="Rounded Rectangle 5"/>
           <p:cNvSpPr/>
           <p:nvPr/>
         </p:nvSpPr>
         <p:spPr>
           <a:xfrm>
-            <a:off x="622300" y="2336800"/>
-            <a:ext cx="6807200" cy="1752600"/>
+            <a:off x="622300" y="2463800"/>
+            <a:ext cx="7162800" cy="698500"/>
           </a:xfrm>
           <a:prstGeom prst="roundRect">
             <a:avLst>
@@ -11911,196 +12046,14 @@
       </p:sp>
       <p:sp>
         <p:nvSpPr>
-          <p:cNvPr id="5" name="TextBox 4"/>
-          <p:cNvSpPr txBox="1"/>
-          <p:nvPr/>
-        </p:nvSpPr>
-        <p:spPr>
-          <a:xfrm>
-            <a:off x="850900" y="2540000"/>
-            <a:ext cx="6197600" cy="382727"/>
-          </a:xfrm>
-          <a:prstGeom prst="rect">
-            <a:avLst/>
-          </a:prstGeom>
-          <a:noFill/>
-        </p:spPr>
-        <p:txBody>
-          <a:bodyPr wrap="none" tIns="0" bIns="0" lIns="0" rIns="0" anchor="t">
-            <a:noAutofit/>
-          </a:bodyPr>
-          <a:lstStyle/>
-          <a:p>
-            <a:pPr algn="l">
-              <a:lnSpc>
-                <a:spcPts val="2713"/>
-              </a:lnSpc>
-              <a:spcBef>
-                <a:spcPts val="0"/>
-              </a:spcBef>
-              <a:spcAft>
-                <a:spcPts val="0"/>
-              </a:spcAft>
-            </a:pPr>
-            <a:r>
-              <a:rPr sz="2120" b="1">
-                <a:solidFill>
-                  <a:srgbClr val="1F1931"/>
-                </a:solidFill>
-                <a:latin typeface="Arial"/>
-              </a:rPr>
-              <a:t>Исмаилов Ислам Шафикович</a:t>
-            </a:r>
-          </a:p>
-        </p:txBody>
-      </p:sp>
-      <p:sp>
-        <p:nvSpPr>
-          <p:cNvPr id="6" name="TextBox 5"/>
-          <p:cNvSpPr txBox="1"/>
-          <p:nvPr/>
-        </p:nvSpPr>
-        <p:spPr>
-          <a:xfrm>
-            <a:off x="850900" y="2971800"/>
-            <a:ext cx="6223000" cy="285191"/>
-          </a:xfrm>
-          <a:prstGeom prst="rect">
-            <a:avLst/>
-          </a:prstGeom>
-          <a:noFill/>
-        </p:spPr>
-        <p:txBody>
-          <a:bodyPr wrap="none" tIns="0" bIns="0" lIns="0" rIns="0" anchor="t">
-            <a:noAutofit/>
-          </a:bodyPr>
-          <a:lstStyle/>
-          <a:p>
-            <a:pPr algn="l">
-              <a:lnSpc>
-                <a:spcPts val="1945"/>
-              </a:lnSpc>
-              <a:spcBef>
-                <a:spcPts val="0"/>
-              </a:spcBef>
-              <a:spcAft>
-                <a:spcPts val="0"/>
-              </a:spcAft>
-            </a:pPr>
-            <a:r>
-              <a:rPr sz="1520" b="0">
-                <a:solidFill>
-                  <a:srgbClr val="57228A"/>
-                </a:solidFill>
-                <a:latin typeface="Arial"/>
-              </a:rPr>
-              <a:t>Контакт проекта «СинтексПруф»</a:t>
-            </a:r>
-          </a:p>
-        </p:txBody>
-      </p:sp>
-      <p:sp>
-        <p:nvSpPr>
-          <p:cNvPr id="7" name="TextBox 6"/>
-          <p:cNvSpPr txBox="1"/>
-          <p:nvPr/>
-        </p:nvSpPr>
-        <p:spPr>
-          <a:xfrm>
-            <a:off x="850900" y="3352800"/>
-            <a:ext cx="6273800" cy="487375"/>
-          </a:xfrm>
-          <a:prstGeom prst="rect">
-            <a:avLst/>
-          </a:prstGeom>
-          <a:noFill/>
-        </p:spPr>
-        <p:txBody>
-          <a:bodyPr wrap="none" tIns="0" bIns="0" lIns="0" rIns="0" anchor="t">
-            <a:noAutofit/>
-          </a:bodyPr>
-          <a:lstStyle/>
-          <a:p>
-            <a:pPr algn="l">
-              <a:lnSpc>
-                <a:spcPts val="1768"/>
-              </a:lnSpc>
-              <a:spcBef>
-                <a:spcPts val="0"/>
-              </a:spcBef>
-              <a:spcAft>
-                <a:spcPts val="0"/>
-              </a:spcAft>
-            </a:pPr>
-            <a:r>
-              <a:rPr sz="1320" b="0">
-                <a:solidFill>
-                  <a:srgbClr val="5A526C"/>
-                </a:solidFill>
-                <a:latin typeface="Arial"/>
-              </a:rPr>
-              <a:t>StevenScreamches@ya.ru_x000B_+7 (928) 218-30-30</a:t>
-            </a:r>
-          </a:p>
-        </p:txBody>
-      </p:sp>
-      <p:sp>
-        <p:nvSpPr>
-          <p:cNvPr id="8" name="Rounded Rectangle 7"/>
+          <p:cNvPr id="7" name="Rectangle 6"/>
           <p:cNvSpPr/>
           <p:nvPr/>
         </p:nvSpPr>
         <p:spPr>
           <a:xfrm>
-            <a:off x="622300" y="4330700"/>
-            <a:ext cx="6807200" cy="1333500"/>
-          </a:xfrm>
-          <a:prstGeom prst="roundRect">
-            <a:avLst>
-              <a:gd name="adj" fmla="val 11000"/>
-            </a:avLst>
-          </a:prstGeom>
-          <a:solidFill>
-            <a:srgbClr val="FFFFFF"/>
-          </a:solidFill>
-          <a:ln w="9525">
-            <a:solidFill>
-              <a:srgbClr val="D9CDE9"/>
-            </a:solidFill>
-          </a:ln>
-        </p:spPr>
-        <p:style>
-          <a:lnRef idx="1">
-            <a:schemeClr val="accent1"/>
-          </a:lnRef>
-          <a:fillRef idx="3">
-            <a:schemeClr val="accent1"/>
-          </a:fillRef>
-          <a:effectRef idx="2">
-            <a:schemeClr val="accent1"/>
-          </a:effectRef>
-          <a:fontRef idx="minor">
-            <a:schemeClr val="lt1"/>
-          </a:fontRef>
-        </p:style>
-        <p:txBody>
-          <a:bodyPr rtlCol="0" anchor="ctr"/>
-          <a:lstStyle/>
-          <a:p>
-            <a:pPr algn="ctr"/>
-          </a:p>
-        </p:txBody>
-      </p:sp>
-      <p:sp>
-        <p:nvSpPr>
-          <p:cNvPr id="9" name="Rectangle 8"/>
-          <p:cNvSpPr/>
-          <p:nvPr/>
-        </p:nvSpPr>
-        <p:spPr>
-          <a:xfrm>
-            <a:off x="774700" y="4521200"/>
-            <a:ext cx="50800" cy="952500"/>
+            <a:off x="774700" y="2590800"/>
+            <a:ext cx="50800" cy="444500"/>
           </a:xfrm>
           <a:prstGeom prst="rect">
             <a:avLst/>
@@ -12136,148 +12089,1048 @@
       </p:sp>
       <p:sp>
         <p:nvSpPr>
+          <p:cNvPr id="8" name="TextBox 7"/>
+          <p:cNvSpPr txBox="1"/>
+          <p:nvPr/>
+        </p:nvSpPr>
+        <p:spPr>
+          <a:xfrm>
+            <a:off x="939800" y="2540000"/>
+            <a:ext cx="4508500" cy="257556"/>
+          </a:xfrm>
+          <a:prstGeom prst="rect">
+            <a:avLst/>
+          </a:prstGeom>
+          <a:noFill/>
+        </p:spPr>
+        <p:txBody>
+          <a:bodyPr wrap="none" tIns="0" bIns="0" lIns="0" rIns="0" anchor="t">
+            <a:noAutofit/>
+          </a:bodyPr>
+          <a:lstStyle/>
+          <a:p>
+            <a:pPr algn="l">
+              <a:lnSpc>
+                <a:spcPts val="1728"/>
+              </a:lnSpc>
+              <a:spcBef>
+                <a:spcPts val="0"/>
+              </a:spcBef>
+              <a:spcAft>
+                <a:spcPts val="0"/>
+              </a:spcAft>
+            </a:pPr>
+            <a:r>
+              <a:rPr sz="1350" b="1">
+                <a:solidFill>
+                  <a:srgbClr val="1F1931"/>
+                </a:solidFill>
+                <a:latin typeface="Arial"/>
+              </a:rPr>
+              <a:t>Исмаилов Ислам Шафикович</a:t>
+            </a:r>
+          </a:p>
+        </p:txBody>
+      </p:sp>
+      <p:sp>
+        <p:nvSpPr>
+          <p:cNvPr id="9" name="TextBox 8"/>
+          <p:cNvSpPr txBox="1"/>
+          <p:nvPr/>
+        </p:nvSpPr>
+        <p:spPr>
+          <a:xfrm>
+            <a:off x="5499100" y="2578100"/>
+            <a:ext cx="2108200" cy="199034"/>
+          </a:xfrm>
+          <a:prstGeom prst="rect">
+            <a:avLst/>
+          </a:prstGeom>
+          <a:noFill/>
+        </p:spPr>
+        <p:txBody>
+          <a:bodyPr wrap="none" tIns="0" bIns="0" lIns="0" rIns="0" anchor="t">
+            <a:noAutofit/>
+          </a:bodyPr>
+          <a:lstStyle/>
+          <a:p>
+            <a:pPr algn="r">
+              <a:lnSpc>
+                <a:spcPts val="1267"/>
+              </a:lnSpc>
+              <a:spcBef>
+                <a:spcPts val="0"/>
+              </a:spcBef>
+              <a:spcAft>
+                <a:spcPts val="0"/>
+              </a:spcAft>
+            </a:pPr>
+            <a:r>
+              <a:rPr sz="990" b="0">
+                <a:solidFill>
+                  <a:srgbClr val="57228A"/>
+                </a:solidFill>
+                <a:latin typeface="Arial"/>
+              </a:rPr>
+              <a:t>U2579564 / 7124087</a:t>
+            </a:r>
+          </a:p>
+        </p:txBody>
+      </p:sp>
+      <p:sp>
+        <p:nvSpPr>
           <p:cNvPr id="10" name="TextBox 9"/>
           <p:cNvSpPr txBox="1"/>
           <p:nvPr/>
         </p:nvSpPr>
         <p:spPr>
           <a:xfrm>
-            <a:off x="965200" y="4470400"/>
-            <a:ext cx="6273800" cy="301447"/>
-          </a:xfrm>
-          <a:prstGeom prst="rect">
-            <a:avLst/>
-          </a:prstGeom>
-          <a:noFill/>
-        </p:spPr>
-        <p:txBody>
-          <a:bodyPr wrap="none" tIns="0" bIns="0" lIns="0" rIns="0" anchor="t">
-            <a:noAutofit/>
-          </a:bodyPr>
-          <a:lstStyle/>
-          <a:p>
-            <a:pPr algn="l">
-              <a:lnSpc>
-                <a:spcPts val="2073"/>
-              </a:lnSpc>
-              <a:spcBef>
-                <a:spcPts val="0"/>
-              </a:spcBef>
-              <a:spcAft>
-                <a:spcPts val="0"/>
-              </a:spcAft>
-            </a:pPr>
-            <a:r>
-              <a:rPr sz="1620" b="1">
+            <a:off x="939800" y="2857500"/>
+            <a:ext cx="6654800" cy="218541"/>
+          </a:xfrm>
+          <a:prstGeom prst="rect">
+            <a:avLst/>
+          </a:prstGeom>
+          <a:noFill/>
+        </p:spPr>
+        <p:txBody>
+          <a:bodyPr wrap="none" tIns="0" bIns="0" lIns="0" rIns="0" anchor="t">
+            <a:noAutofit/>
+          </a:bodyPr>
+          <a:lstStyle/>
+          <a:p>
+            <a:pPr algn="l">
+              <a:lnSpc>
+                <a:spcPts val="1420"/>
+              </a:lnSpc>
+              <a:spcBef>
+                <a:spcPts val="0"/>
+              </a:spcBef>
+              <a:spcAft>
+                <a:spcPts val="0"/>
+              </a:spcAft>
+            </a:pPr>
+            <a:r>
+              <a:rPr sz="1110" b="0">
+                <a:solidFill>
+                  <a:srgbClr val="5A526C"/>
+                </a:solidFill>
+                <a:latin typeface="Arial"/>
+              </a:rPr>
+              <a:t>Руководитель проекта · Тимлид</a:t>
+            </a:r>
+          </a:p>
+        </p:txBody>
+      </p:sp>
+      <p:sp>
+        <p:nvSpPr>
+          <p:cNvPr id="11" name="Rounded Rectangle 10"/>
+          <p:cNvSpPr/>
+          <p:nvPr/>
+        </p:nvSpPr>
+        <p:spPr>
+          <a:xfrm>
+            <a:off x="622300" y="3238500"/>
+            <a:ext cx="7162800" cy="698500"/>
+          </a:xfrm>
+          <a:prstGeom prst="roundRect">
+            <a:avLst>
+              <a:gd name="adj" fmla="val 11000"/>
+            </a:avLst>
+          </a:prstGeom>
+          <a:solidFill>
+            <a:srgbClr val="FFFFFF"/>
+          </a:solidFill>
+          <a:ln w="10160">
+            <a:solidFill>
+              <a:srgbClr val="D9CDE9"/>
+            </a:solidFill>
+          </a:ln>
+        </p:spPr>
+        <p:style>
+          <a:lnRef idx="1">
+            <a:schemeClr val="accent1"/>
+          </a:lnRef>
+          <a:fillRef idx="3">
+            <a:schemeClr val="accent1"/>
+          </a:fillRef>
+          <a:effectRef idx="2">
+            <a:schemeClr val="accent1"/>
+          </a:effectRef>
+          <a:fontRef idx="minor">
+            <a:schemeClr val="lt1"/>
+          </a:fontRef>
+        </p:style>
+        <p:txBody>
+          <a:bodyPr rtlCol="0" anchor="ctr"/>
+          <a:lstStyle/>
+          <a:p>
+            <a:pPr algn="ctr"/>
+          </a:p>
+        </p:txBody>
+      </p:sp>
+      <p:sp>
+        <p:nvSpPr>
+          <p:cNvPr id="12" name="Rectangle 11"/>
+          <p:cNvSpPr/>
+          <p:nvPr/>
+        </p:nvSpPr>
+        <p:spPr>
+          <a:xfrm>
+            <a:off x="774700" y="3365500"/>
+            <a:ext cx="50800" cy="444500"/>
+          </a:xfrm>
+          <a:prstGeom prst="rect">
+            <a:avLst/>
+          </a:prstGeom>
+          <a:solidFill>
+            <a:srgbClr val="8423C1"/>
+          </a:solidFill>
+          <a:ln>
+            <a:noFill/>
+          </a:ln>
+        </p:spPr>
+        <p:style>
+          <a:lnRef idx="1">
+            <a:schemeClr val="accent1"/>
+          </a:lnRef>
+          <a:fillRef idx="3">
+            <a:schemeClr val="accent1"/>
+          </a:fillRef>
+          <a:effectRef idx="2">
+            <a:schemeClr val="accent1"/>
+          </a:effectRef>
+          <a:fontRef idx="minor">
+            <a:schemeClr val="lt1"/>
+          </a:fontRef>
+        </p:style>
+        <p:txBody>
+          <a:bodyPr rtlCol="0" anchor="ctr"/>
+          <a:lstStyle/>
+          <a:p>
+            <a:pPr algn="ctr"/>
+          </a:p>
+        </p:txBody>
+      </p:sp>
+      <p:sp>
+        <p:nvSpPr>
+          <p:cNvPr id="13" name="TextBox 12"/>
+          <p:cNvSpPr txBox="1"/>
+          <p:nvPr/>
+        </p:nvSpPr>
+        <p:spPr>
+          <a:xfrm>
+            <a:off x="939800" y="3314700"/>
+            <a:ext cx="4508500" cy="257556"/>
+          </a:xfrm>
+          <a:prstGeom prst="rect">
+            <a:avLst/>
+          </a:prstGeom>
+          <a:noFill/>
+        </p:spPr>
+        <p:txBody>
+          <a:bodyPr wrap="none" tIns="0" bIns="0" lIns="0" rIns="0" anchor="t">
+            <a:noAutofit/>
+          </a:bodyPr>
+          <a:lstStyle/>
+          <a:p>
+            <a:pPr algn="l">
+              <a:lnSpc>
+                <a:spcPts val="1728"/>
+              </a:lnSpc>
+              <a:spcBef>
+                <a:spcPts val="0"/>
+              </a:spcBef>
+              <a:spcAft>
+                <a:spcPts val="0"/>
+              </a:spcAft>
+            </a:pPr>
+            <a:r>
+              <a:rPr sz="1350" b="1">
                 <a:solidFill>
                   <a:srgbClr val="1F1931"/>
                 </a:solidFill>
                 <a:latin typeface="Arial"/>
               </a:rPr>
-              <a:t>Компетенции для усиления</a:t>
-            </a:r>
-          </a:p>
-        </p:txBody>
-      </p:sp>
-      <p:sp>
-        <p:nvSpPr>
-          <p:cNvPr id="11" name="TextBox 10"/>
-          <p:cNvSpPr txBox="1"/>
-          <p:nvPr/>
-        </p:nvSpPr>
-        <p:spPr>
-          <a:xfrm>
-            <a:off x="965200" y="4889500"/>
-            <a:ext cx="6248400" cy="252679"/>
-          </a:xfrm>
-          <a:prstGeom prst="rect">
-            <a:avLst/>
-          </a:prstGeom>
-          <a:noFill/>
-        </p:spPr>
-        <p:txBody>
-          <a:bodyPr wrap="none" tIns="0" bIns="0" lIns="0" rIns="0" anchor="t">
-            <a:noAutofit/>
-          </a:bodyPr>
-          <a:lstStyle/>
-          <a:p>
-            <a:pPr algn="l">
-              <a:lnSpc>
-                <a:spcPts val="1689"/>
-              </a:lnSpc>
-              <a:spcBef>
-                <a:spcPts val="0"/>
-              </a:spcBef>
-              <a:spcAft>
-                <a:spcPts val="0"/>
-              </a:spcAft>
-            </a:pPr>
-            <a:r>
-              <a:rPr sz="1320" b="0">
+              <a:t>Яхьяев Абдуллах Закарьяевич</a:t>
+            </a:r>
+          </a:p>
+        </p:txBody>
+      </p:sp>
+      <p:sp>
+        <p:nvSpPr>
+          <p:cNvPr id="14" name="TextBox 13"/>
+          <p:cNvSpPr txBox="1"/>
+          <p:nvPr/>
+        </p:nvSpPr>
+        <p:spPr>
+          <a:xfrm>
+            <a:off x="5499100" y="3352800"/>
+            <a:ext cx="2108200" cy="199034"/>
+          </a:xfrm>
+          <a:prstGeom prst="rect">
+            <a:avLst/>
+          </a:prstGeom>
+          <a:noFill/>
+        </p:spPr>
+        <p:txBody>
+          <a:bodyPr wrap="none" tIns="0" bIns="0" lIns="0" rIns="0" anchor="t">
+            <a:noAutofit/>
+          </a:bodyPr>
+          <a:lstStyle/>
+          <a:p>
+            <a:pPr algn="r">
+              <a:lnSpc>
+                <a:spcPts val="1267"/>
+              </a:lnSpc>
+              <a:spcBef>
+                <a:spcPts val="0"/>
+              </a:spcBef>
+              <a:spcAft>
+                <a:spcPts val="0"/>
+              </a:spcAft>
+            </a:pPr>
+            <a:r>
+              <a:rPr sz="990" b="0">
+                <a:solidFill>
+                  <a:srgbClr val="57228A"/>
+                </a:solidFill>
+                <a:latin typeface="Arial"/>
+              </a:rPr>
+              <a:t>U2579613 / 7675623</a:t>
+            </a:r>
+          </a:p>
+        </p:txBody>
+      </p:sp>
+      <p:sp>
+        <p:nvSpPr>
+          <p:cNvPr id="15" name="TextBox 14"/>
+          <p:cNvSpPr txBox="1"/>
+          <p:nvPr/>
+        </p:nvSpPr>
+        <p:spPr>
+          <a:xfrm>
+            <a:off x="939800" y="3632200"/>
+            <a:ext cx="6654800" cy="218541"/>
+          </a:xfrm>
+          <a:prstGeom prst="rect">
+            <a:avLst/>
+          </a:prstGeom>
+          <a:noFill/>
+        </p:spPr>
+        <p:txBody>
+          <a:bodyPr wrap="none" tIns="0" bIns="0" lIns="0" rIns="0" anchor="t">
+            <a:noAutofit/>
+          </a:bodyPr>
+          <a:lstStyle/>
+          <a:p>
+            <a:pPr algn="l">
+              <a:lnSpc>
+                <a:spcPts val="1420"/>
+              </a:lnSpc>
+              <a:spcBef>
+                <a:spcPts val="0"/>
+              </a:spcBef>
+              <a:spcAft>
+                <a:spcPts val="0"/>
+              </a:spcAft>
+            </a:pPr>
+            <a:r>
+              <a:rPr sz="1110" b="0">
                 <a:solidFill>
                   <a:srgbClr val="5A526C"/>
                 </a:solidFill>
                 <a:latin typeface="Arial"/>
               </a:rPr>
-              <a:t>Инженерия анализа кода · ИИ/ML · продукт и B2B-пилоты</a:t>
-            </a:r>
-          </a:p>
-        </p:txBody>
-      </p:sp>
-      <p:sp>
-        <p:nvSpPr>
-          <p:cNvPr id="12" name="TextBox 11"/>
-          <p:cNvSpPr txBox="1"/>
-          <p:nvPr/>
-        </p:nvSpPr>
-        <p:spPr>
-          <a:xfrm>
-            <a:off x="647700" y="5854700"/>
-            <a:ext cx="6959600" cy="223418"/>
-          </a:xfrm>
-          <a:prstGeom prst="rect">
-            <a:avLst/>
-          </a:prstGeom>
-          <a:noFill/>
-        </p:spPr>
-        <p:txBody>
-          <a:bodyPr wrap="none" tIns="0" bIns="0" lIns="0" rIns="0" anchor="t">
-            <a:noAutofit/>
-          </a:bodyPr>
-          <a:lstStyle/>
-          <a:p>
-            <a:pPr algn="l">
-              <a:lnSpc>
-                <a:spcPts val="1459"/>
-              </a:lnSpc>
-              <a:spcBef>
-                <a:spcPts val="0"/>
-              </a:spcBef>
-              <a:spcAft>
-                <a:spcPts val="0"/>
-              </a:spcAft>
-            </a:pPr>
-            <a:r>
-              <a:rPr sz="1140" b="0">
+              <a:t>Технический специалист · Бэкенд-разработчик</a:t>
+            </a:r>
+          </a:p>
+        </p:txBody>
+      </p:sp>
+      <p:sp>
+        <p:nvSpPr>
+          <p:cNvPr id="16" name="Rounded Rectangle 15"/>
+          <p:cNvSpPr/>
+          <p:nvPr/>
+        </p:nvSpPr>
+        <p:spPr>
+          <a:xfrm>
+            <a:off x="622300" y="4013200"/>
+            <a:ext cx="7162800" cy="698500"/>
+          </a:xfrm>
+          <a:prstGeom prst="roundRect">
+            <a:avLst>
+              <a:gd name="adj" fmla="val 11000"/>
+            </a:avLst>
+          </a:prstGeom>
+          <a:solidFill>
+            <a:srgbClr val="FFFFFF"/>
+          </a:solidFill>
+          <a:ln w="10160">
+            <a:solidFill>
+              <a:srgbClr val="D9CDE9"/>
+            </a:solidFill>
+          </a:ln>
+        </p:spPr>
+        <p:style>
+          <a:lnRef idx="1">
+            <a:schemeClr val="accent1"/>
+          </a:lnRef>
+          <a:fillRef idx="3">
+            <a:schemeClr val="accent1"/>
+          </a:fillRef>
+          <a:effectRef idx="2">
+            <a:schemeClr val="accent1"/>
+          </a:effectRef>
+          <a:fontRef idx="minor">
+            <a:schemeClr val="lt1"/>
+          </a:fontRef>
+        </p:style>
+        <p:txBody>
+          <a:bodyPr rtlCol="0" anchor="ctr"/>
+          <a:lstStyle/>
+          <a:p>
+            <a:pPr algn="ctr"/>
+          </a:p>
+        </p:txBody>
+      </p:sp>
+      <p:sp>
+        <p:nvSpPr>
+          <p:cNvPr id="17" name="Rectangle 16"/>
+          <p:cNvSpPr/>
+          <p:nvPr/>
+        </p:nvSpPr>
+        <p:spPr>
+          <a:xfrm>
+            <a:off x="774700" y="4140200"/>
+            <a:ext cx="50800" cy="444500"/>
+          </a:xfrm>
+          <a:prstGeom prst="rect">
+            <a:avLst/>
+          </a:prstGeom>
+          <a:solidFill>
+            <a:srgbClr val="8423C1"/>
+          </a:solidFill>
+          <a:ln>
+            <a:noFill/>
+          </a:ln>
+        </p:spPr>
+        <p:style>
+          <a:lnRef idx="1">
+            <a:schemeClr val="accent1"/>
+          </a:lnRef>
+          <a:fillRef idx="3">
+            <a:schemeClr val="accent1"/>
+          </a:fillRef>
+          <a:effectRef idx="2">
+            <a:schemeClr val="accent1"/>
+          </a:effectRef>
+          <a:fontRef idx="minor">
+            <a:schemeClr val="lt1"/>
+          </a:fontRef>
+        </p:style>
+        <p:txBody>
+          <a:bodyPr rtlCol="0" anchor="ctr"/>
+          <a:lstStyle/>
+          <a:p>
+            <a:pPr algn="ctr"/>
+          </a:p>
+        </p:txBody>
+      </p:sp>
+      <p:sp>
+        <p:nvSpPr>
+          <p:cNvPr id="18" name="TextBox 17"/>
+          <p:cNvSpPr txBox="1"/>
+          <p:nvPr/>
+        </p:nvSpPr>
+        <p:spPr>
+          <a:xfrm>
+            <a:off x="939800" y="4089400"/>
+            <a:ext cx="4508500" cy="257556"/>
+          </a:xfrm>
+          <a:prstGeom prst="rect">
+            <a:avLst/>
+          </a:prstGeom>
+          <a:noFill/>
+        </p:spPr>
+        <p:txBody>
+          <a:bodyPr wrap="none" tIns="0" bIns="0" lIns="0" rIns="0" anchor="t">
+            <a:noAutofit/>
+          </a:bodyPr>
+          <a:lstStyle/>
+          <a:p>
+            <a:pPr algn="l">
+              <a:lnSpc>
+                <a:spcPts val="1728"/>
+              </a:lnSpc>
+              <a:spcBef>
+                <a:spcPts val="0"/>
+              </a:spcBef>
+              <a:spcAft>
+                <a:spcPts val="0"/>
+              </a:spcAft>
+            </a:pPr>
+            <a:r>
+              <a:rPr sz="1350" b="1">
+                <a:solidFill>
+                  <a:srgbClr val="1F1931"/>
+                </a:solidFill>
+                <a:latin typeface="Arial"/>
+              </a:rPr>
+              <a:t>Загиров Алимагомед Мурадович</a:t>
+            </a:r>
+          </a:p>
+        </p:txBody>
+      </p:sp>
+      <p:sp>
+        <p:nvSpPr>
+          <p:cNvPr id="19" name="TextBox 18"/>
+          <p:cNvSpPr txBox="1"/>
+          <p:nvPr/>
+        </p:nvSpPr>
+        <p:spPr>
+          <a:xfrm>
+            <a:off x="5499100" y="4127500"/>
+            <a:ext cx="2108200" cy="199034"/>
+          </a:xfrm>
+          <a:prstGeom prst="rect">
+            <a:avLst/>
+          </a:prstGeom>
+          <a:noFill/>
+        </p:spPr>
+        <p:txBody>
+          <a:bodyPr wrap="none" tIns="0" bIns="0" lIns="0" rIns="0" anchor="t">
+            <a:noAutofit/>
+          </a:bodyPr>
+          <a:lstStyle/>
+          <a:p>
+            <a:pPr algn="r">
+              <a:lnSpc>
+                <a:spcPts val="1267"/>
+              </a:lnSpc>
+              <a:spcBef>
+                <a:spcPts val="0"/>
+              </a:spcBef>
+              <a:spcAft>
+                <a:spcPts val="0"/>
+              </a:spcAft>
+            </a:pPr>
+            <a:r>
+              <a:rPr sz="990" b="0">
+                <a:solidFill>
+                  <a:srgbClr val="57228A"/>
+                </a:solidFill>
+                <a:latin typeface="Arial"/>
+              </a:rPr>
+              <a:t>U1836974 / 4870356</a:t>
+            </a:r>
+          </a:p>
+        </p:txBody>
+      </p:sp>
+      <p:sp>
+        <p:nvSpPr>
+          <p:cNvPr id="20" name="TextBox 19"/>
+          <p:cNvSpPr txBox="1"/>
+          <p:nvPr/>
+        </p:nvSpPr>
+        <p:spPr>
+          <a:xfrm>
+            <a:off x="939800" y="4406900"/>
+            <a:ext cx="6654800" cy="218541"/>
+          </a:xfrm>
+          <a:prstGeom prst="rect">
+            <a:avLst/>
+          </a:prstGeom>
+          <a:noFill/>
+        </p:spPr>
+        <p:txBody>
+          <a:bodyPr wrap="none" tIns="0" bIns="0" lIns="0" rIns="0" anchor="t">
+            <a:noAutofit/>
+          </a:bodyPr>
+          <a:lstStyle/>
+          <a:p>
+            <a:pPr algn="l">
+              <a:lnSpc>
+                <a:spcPts val="1420"/>
+              </a:lnSpc>
+              <a:spcBef>
+                <a:spcPts val="0"/>
+              </a:spcBef>
+              <a:spcAft>
+                <a:spcPts val="0"/>
+              </a:spcAft>
+            </a:pPr>
+            <a:r>
+              <a:rPr sz="1110" b="0">
                 <a:solidFill>
                   <a:srgbClr val="5A526C"/>
                 </a:solidFill>
                 <a:latin typeface="Arial"/>
               </a:rPr>
-              <a:t>Вуз, курс, опыт и полный состав команды в источниках не приведены.</a:t>
-            </a:r>
-          </a:p>
-        </p:txBody>
-      </p:sp>
-      <p:sp>
-        <p:nvSpPr>
-          <p:cNvPr id="13" name="TextBox 12"/>
-          <p:cNvSpPr txBox="1"/>
-          <p:nvPr/>
-        </p:nvSpPr>
-        <p:spPr>
-          <a:xfrm>
-            <a:off x="609600" y="6502400"/>
+              <a:t>Бизнес-аналитик · Продуктовый аналитик</a:t>
+            </a:r>
+          </a:p>
+        </p:txBody>
+      </p:sp>
+      <p:sp>
+        <p:nvSpPr>
+          <p:cNvPr id="21" name="Rounded Rectangle 20"/>
+          <p:cNvSpPr/>
+          <p:nvPr/>
+        </p:nvSpPr>
+        <p:spPr>
+          <a:xfrm>
+            <a:off x="622300" y="4787900"/>
+            <a:ext cx="7162800" cy="698500"/>
+          </a:xfrm>
+          <a:prstGeom prst="roundRect">
+            <a:avLst>
+              <a:gd name="adj" fmla="val 11000"/>
+            </a:avLst>
+          </a:prstGeom>
+          <a:solidFill>
+            <a:srgbClr val="FFFFFF"/>
+          </a:solidFill>
+          <a:ln w="10160">
+            <a:solidFill>
+              <a:srgbClr val="D9CDE9"/>
+            </a:solidFill>
+          </a:ln>
+        </p:spPr>
+        <p:style>
+          <a:lnRef idx="1">
+            <a:schemeClr val="accent1"/>
+          </a:lnRef>
+          <a:fillRef idx="3">
+            <a:schemeClr val="accent1"/>
+          </a:fillRef>
+          <a:effectRef idx="2">
+            <a:schemeClr val="accent1"/>
+          </a:effectRef>
+          <a:fontRef idx="minor">
+            <a:schemeClr val="lt1"/>
+          </a:fontRef>
+        </p:style>
+        <p:txBody>
+          <a:bodyPr rtlCol="0" anchor="ctr"/>
+          <a:lstStyle/>
+          <a:p>
+            <a:pPr algn="ctr"/>
+          </a:p>
+        </p:txBody>
+      </p:sp>
+      <p:sp>
+        <p:nvSpPr>
+          <p:cNvPr id="22" name="Rectangle 21"/>
+          <p:cNvSpPr/>
+          <p:nvPr/>
+        </p:nvSpPr>
+        <p:spPr>
+          <a:xfrm>
+            <a:off x="774700" y="4914900"/>
+            <a:ext cx="50800" cy="444500"/>
+          </a:xfrm>
+          <a:prstGeom prst="rect">
+            <a:avLst/>
+          </a:prstGeom>
+          <a:solidFill>
+            <a:srgbClr val="8423C1"/>
+          </a:solidFill>
+          <a:ln>
+            <a:noFill/>
+          </a:ln>
+        </p:spPr>
+        <p:style>
+          <a:lnRef idx="1">
+            <a:schemeClr val="accent1"/>
+          </a:lnRef>
+          <a:fillRef idx="3">
+            <a:schemeClr val="accent1"/>
+          </a:fillRef>
+          <a:effectRef idx="2">
+            <a:schemeClr val="accent1"/>
+          </a:effectRef>
+          <a:fontRef idx="minor">
+            <a:schemeClr val="lt1"/>
+          </a:fontRef>
+        </p:style>
+        <p:txBody>
+          <a:bodyPr rtlCol="0" anchor="ctr"/>
+          <a:lstStyle/>
+          <a:p>
+            <a:pPr algn="ctr"/>
+          </a:p>
+        </p:txBody>
+      </p:sp>
+      <p:sp>
+        <p:nvSpPr>
+          <p:cNvPr id="23" name="TextBox 22"/>
+          <p:cNvSpPr txBox="1"/>
+          <p:nvPr/>
+        </p:nvSpPr>
+        <p:spPr>
+          <a:xfrm>
+            <a:off x="939800" y="4864100"/>
+            <a:ext cx="4508500" cy="257556"/>
+          </a:xfrm>
+          <a:prstGeom prst="rect">
+            <a:avLst/>
+          </a:prstGeom>
+          <a:noFill/>
+        </p:spPr>
+        <p:txBody>
+          <a:bodyPr wrap="none" tIns="0" bIns="0" lIns="0" rIns="0" anchor="t">
+            <a:noAutofit/>
+          </a:bodyPr>
+          <a:lstStyle/>
+          <a:p>
+            <a:pPr algn="l">
+              <a:lnSpc>
+                <a:spcPts val="1728"/>
+              </a:lnSpc>
+              <a:spcBef>
+                <a:spcPts val="0"/>
+              </a:spcBef>
+              <a:spcAft>
+                <a:spcPts val="0"/>
+              </a:spcAft>
+            </a:pPr>
+            <a:r>
+              <a:rPr sz="1350" b="1">
+                <a:solidFill>
+                  <a:srgbClr val="1F1931"/>
+                </a:solidFill>
+                <a:latin typeface="Arial"/>
+              </a:rPr>
+              <a:t>Омаров Алиасхаб Рабаданович</a:t>
+            </a:r>
+          </a:p>
+        </p:txBody>
+      </p:sp>
+      <p:sp>
+        <p:nvSpPr>
+          <p:cNvPr id="24" name="TextBox 23"/>
+          <p:cNvSpPr txBox="1"/>
+          <p:nvPr/>
+        </p:nvSpPr>
+        <p:spPr>
+          <a:xfrm>
+            <a:off x="5499100" y="4902200"/>
+            <a:ext cx="2108200" cy="199034"/>
+          </a:xfrm>
+          <a:prstGeom prst="rect">
+            <a:avLst/>
+          </a:prstGeom>
+          <a:noFill/>
+        </p:spPr>
+        <p:txBody>
+          <a:bodyPr wrap="none" tIns="0" bIns="0" lIns="0" rIns="0" anchor="t">
+            <a:noAutofit/>
+          </a:bodyPr>
+          <a:lstStyle/>
+          <a:p>
+            <a:pPr algn="r">
+              <a:lnSpc>
+                <a:spcPts val="1267"/>
+              </a:lnSpc>
+              <a:spcBef>
+                <a:spcPts val="0"/>
+              </a:spcBef>
+              <a:spcAft>
+                <a:spcPts val="0"/>
+              </a:spcAft>
+            </a:pPr>
+            <a:r>
+              <a:rPr sz="990" b="0">
+                <a:solidFill>
+                  <a:srgbClr val="57228A"/>
+                </a:solidFill>
+                <a:latin typeface="Arial"/>
+              </a:rPr>
+              <a:t>U2579569 / 7369083</a:t>
+            </a:r>
+          </a:p>
+        </p:txBody>
+      </p:sp>
+      <p:sp>
+        <p:nvSpPr>
+          <p:cNvPr id="25" name="TextBox 24"/>
+          <p:cNvSpPr txBox="1"/>
+          <p:nvPr/>
+        </p:nvSpPr>
+        <p:spPr>
+          <a:xfrm>
+            <a:off x="939800" y="5181600"/>
+            <a:ext cx="6654800" cy="218541"/>
+          </a:xfrm>
+          <a:prstGeom prst="rect">
+            <a:avLst/>
+          </a:prstGeom>
+          <a:noFill/>
+        </p:spPr>
+        <p:txBody>
+          <a:bodyPr wrap="none" tIns="0" bIns="0" lIns="0" rIns="0" anchor="t">
+            <a:noAutofit/>
+          </a:bodyPr>
+          <a:lstStyle/>
+          <a:p>
+            <a:pPr algn="l">
+              <a:lnSpc>
+                <a:spcPts val="1420"/>
+              </a:lnSpc>
+              <a:spcBef>
+                <a:spcPts val="0"/>
+              </a:spcBef>
+              <a:spcAft>
+                <a:spcPts val="0"/>
+              </a:spcAft>
+            </a:pPr>
+            <a:r>
+              <a:rPr sz="1110" b="0">
+                <a:solidFill>
+                  <a:srgbClr val="5A526C"/>
+                </a:solidFill>
+                <a:latin typeface="Arial"/>
+              </a:rPr>
+              <a:t>Технический специалист · Бэкенд-разработчик</a:t>
+            </a:r>
+          </a:p>
+        </p:txBody>
+      </p:sp>
+      <p:sp>
+        <p:nvSpPr>
+          <p:cNvPr id="26" name="Rounded Rectangle 25"/>
+          <p:cNvSpPr/>
+          <p:nvPr/>
+        </p:nvSpPr>
+        <p:spPr>
+          <a:xfrm>
+            <a:off x="622300" y="5562600"/>
+            <a:ext cx="7162800" cy="698500"/>
+          </a:xfrm>
+          <a:prstGeom prst="roundRect">
+            <a:avLst>
+              <a:gd name="adj" fmla="val 11000"/>
+            </a:avLst>
+          </a:prstGeom>
+          <a:solidFill>
+            <a:srgbClr val="FFFFFF"/>
+          </a:solidFill>
+          <a:ln w="10160">
+            <a:solidFill>
+              <a:srgbClr val="D9CDE9"/>
+            </a:solidFill>
+          </a:ln>
+        </p:spPr>
+        <p:style>
+          <a:lnRef idx="1">
+            <a:schemeClr val="accent1"/>
+          </a:lnRef>
+          <a:fillRef idx="3">
+            <a:schemeClr val="accent1"/>
+          </a:fillRef>
+          <a:effectRef idx="2">
+            <a:schemeClr val="accent1"/>
+          </a:effectRef>
+          <a:fontRef idx="minor">
+            <a:schemeClr val="lt1"/>
+          </a:fontRef>
+        </p:style>
+        <p:txBody>
+          <a:bodyPr rtlCol="0" anchor="ctr"/>
+          <a:lstStyle/>
+          <a:p>
+            <a:pPr algn="ctr"/>
+          </a:p>
+        </p:txBody>
+      </p:sp>
+      <p:sp>
+        <p:nvSpPr>
+          <p:cNvPr id="27" name="Rectangle 26"/>
+          <p:cNvSpPr/>
+          <p:nvPr/>
+        </p:nvSpPr>
+        <p:spPr>
+          <a:xfrm>
+            <a:off x="774700" y="5689600"/>
+            <a:ext cx="50800" cy="444500"/>
+          </a:xfrm>
+          <a:prstGeom prst="rect">
+            <a:avLst/>
+          </a:prstGeom>
+          <a:solidFill>
+            <a:srgbClr val="8423C1"/>
+          </a:solidFill>
+          <a:ln>
+            <a:noFill/>
+          </a:ln>
+        </p:spPr>
+        <p:style>
+          <a:lnRef idx="1">
+            <a:schemeClr val="accent1"/>
+          </a:lnRef>
+          <a:fillRef idx="3">
+            <a:schemeClr val="accent1"/>
+          </a:fillRef>
+          <a:effectRef idx="2">
+            <a:schemeClr val="accent1"/>
+          </a:effectRef>
+          <a:fontRef idx="minor">
+            <a:schemeClr val="lt1"/>
+          </a:fontRef>
+        </p:style>
+        <p:txBody>
+          <a:bodyPr rtlCol="0" anchor="ctr"/>
+          <a:lstStyle/>
+          <a:p>
+            <a:pPr algn="ctr"/>
+          </a:p>
+        </p:txBody>
+      </p:sp>
+      <p:sp>
+        <p:nvSpPr>
+          <p:cNvPr id="28" name="TextBox 27"/>
+          <p:cNvSpPr txBox="1"/>
+          <p:nvPr/>
+        </p:nvSpPr>
+        <p:spPr>
+          <a:xfrm>
+            <a:off x="939800" y="5638800"/>
+            <a:ext cx="4508500" cy="257556"/>
+          </a:xfrm>
+          <a:prstGeom prst="rect">
+            <a:avLst/>
+          </a:prstGeom>
+          <a:noFill/>
+        </p:spPr>
+        <p:txBody>
+          <a:bodyPr wrap="none" tIns="0" bIns="0" lIns="0" rIns="0" anchor="t">
+            <a:noAutofit/>
+          </a:bodyPr>
+          <a:lstStyle/>
+          <a:p>
+            <a:pPr algn="l">
+              <a:lnSpc>
+                <a:spcPts val="1728"/>
+              </a:lnSpc>
+              <a:spcBef>
+                <a:spcPts val="0"/>
+              </a:spcBef>
+              <a:spcAft>
+                <a:spcPts val="0"/>
+              </a:spcAft>
+            </a:pPr>
+            <a:r>
+              <a:rPr sz="1350" b="1">
+                <a:solidFill>
+                  <a:srgbClr val="1F1931"/>
+                </a:solidFill>
+                <a:latin typeface="Arial"/>
+              </a:rPr>
+              <a:t>Магомедов Руслан Шамильевич</a:t>
+            </a:r>
+          </a:p>
+        </p:txBody>
+      </p:sp>
+      <p:sp>
+        <p:nvSpPr>
+          <p:cNvPr id="29" name="TextBox 28"/>
+          <p:cNvSpPr txBox="1"/>
+          <p:nvPr/>
+        </p:nvSpPr>
+        <p:spPr>
+          <a:xfrm>
+            <a:off x="5499100" y="5676900"/>
+            <a:ext cx="2108200" cy="199034"/>
+          </a:xfrm>
+          <a:prstGeom prst="rect">
+            <a:avLst/>
+          </a:prstGeom>
+          <a:noFill/>
+        </p:spPr>
+        <p:txBody>
+          <a:bodyPr wrap="none" tIns="0" bIns="0" lIns="0" rIns="0" anchor="t">
+            <a:noAutofit/>
+          </a:bodyPr>
+          <a:lstStyle/>
+          <a:p>
+            <a:pPr algn="r">
+              <a:lnSpc>
+                <a:spcPts val="1267"/>
+              </a:lnSpc>
+              <a:spcBef>
+                <a:spcPts val="0"/>
+              </a:spcBef>
+              <a:spcAft>
+                <a:spcPts val="0"/>
+              </a:spcAft>
+            </a:pPr>
+            <a:r>
+              <a:rPr sz="990" b="0">
+                <a:solidFill>
+                  <a:srgbClr val="57228A"/>
+                </a:solidFill>
+                <a:latin typeface="Arial"/>
+              </a:rPr>
+              <a:t>U2579575 / 7688556</a:t>
+            </a:r>
+          </a:p>
+        </p:txBody>
+      </p:sp>
+      <p:sp>
+        <p:nvSpPr>
+          <p:cNvPr id="30" name="TextBox 29"/>
+          <p:cNvSpPr txBox="1"/>
+          <p:nvPr/>
+        </p:nvSpPr>
+        <p:spPr>
+          <a:xfrm>
+            <a:off x="939800" y="5956300"/>
+            <a:ext cx="6654800" cy="218541"/>
+          </a:xfrm>
+          <a:prstGeom prst="rect">
+            <a:avLst/>
+          </a:prstGeom>
+          <a:noFill/>
+        </p:spPr>
+        <p:txBody>
+          <a:bodyPr wrap="none" tIns="0" bIns="0" lIns="0" rIns="0" anchor="t">
+            <a:noAutofit/>
+          </a:bodyPr>
+          <a:lstStyle/>
+          <a:p>
+            <a:pPr algn="l">
+              <a:lnSpc>
+                <a:spcPts val="1420"/>
+              </a:lnSpc>
+              <a:spcBef>
+                <a:spcPts val="0"/>
+              </a:spcBef>
+              <a:spcAft>
+                <a:spcPts val="0"/>
+              </a:spcAft>
+            </a:pPr>
+            <a:r>
+              <a:rPr sz="1110" b="0">
+                <a:solidFill>
+                  <a:srgbClr val="5A526C"/>
+                </a:solidFill>
+                <a:latin typeface="Arial"/>
+              </a:rPr>
+              <a:t>Дизайнер · Фронтенд-разработчик, UX/UI дизайнер</a:t>
+            </a:r>
+          </a:p>
+        </p:txBody>
+      </p:sp>
+      <p:sp>
+        <p:nvSpPr>
+          <p:cNvPr id="31" name="TextBox 30"/>
+          <p:cNvSpPr txBox="1"/>
+          <p:nvPr/>
+        </p:nvSpPr>
+        <p:spPr>
+          <a:xfrm>
+            <a:off x="609600" y="6553200"/>
             <a:ext cx="10756900" cy="142240"/>
           </a:xfrm>
           <a:prstGeom prst="rect">
@@ -12309,7 +13162,7 @@
                 </a:solidFill>
                 <a:latin typeface="Arial"/>
               </a:rPr>
-              <a:t>Источник контактов: «Акселератор.pdf», с. 6. Роли для усиления — предложение.</a:t>
+              <a:t>Источник: анкета проекта (приложенное изображение); вуз, курс и опыт не указаны.</a:t>
             </a:r>
           </a:p>
         </p:txBody>

</xml_diff>